<commit_message>
fix: replace CTA jargon with llamadas a la acción
Co-authored-by: Cursor <cursoragent@cursor.com>
</commit_message>
<xml_diff>
--- a/curso-web-aje-ourense/taller-web-aje-ourense.pptx
+++ b/curso-web-aje-ourense/taller-web-aje-ourense.pptx
@@ -6228,7 +6228,7 @@
                 </a:solidFill>
                 <a:latin typeface="Arial"/>
               </a:rPr>
-              <a:t>Con lo que sabes de mí, crea WEB.md (propuesta, servicios, tono, CTAs) y PERSONAL.md (quién soy, trayectoria, valores). Cortos y accionables.</a:t>
+              <a:t>Con lo que sabes de mí, crea WEB.md (propuesta, servicios, tono, llamadas a la acción) y PERSONAL.md (quién soy, trayectoria, valores). Cortos y accionables.</a:t>
             </a:r>
           </a:p>
         </p:txBody>
@@ -7505,7 +7505,7 @@
                 </a:solidFill>
                 <a:latin typeface="Arial"/>
               </a:rPr>
-              <a:t>Con mis MD de tono, buyer y web, escribe 3 mails: bienvenida, oferta clara y seguimiento. Misma voz. Asunto + cuerpo + CTA.</a:t>
+              <a:t>Con mis MD de tono, buyer y web, escribe 3 mails: bienvenida, oferta clara y seguimiento. Misma voz. Asunto + cuerpo + llamada a la acción.</a:t>
             </a:r>
           </a:p>
         </p:txBody>

</xml_diff>

<commit_message>
fix: teach logo creation process with clearer Gemini prompt
Co-authored-by: Cursor <cursoragent@cursor.com>
</commit_message>
<xml_diff>
--- a/curso-web-aje-ourense/taller-web-aje-ourense.pptx
+++ b/curso-web-aje-ourense/taller-web-aje-ourense.pptx
@@ -7821,7 +7821,7 @@
                 </a:solidFill>
                 <a:latin typeface="Arial"/>
               </a:rPr>
-              <a:t>Prompt</a:t>
+              <a:t>Cómo funciona</a:t>
             </a:r>
           </a:p>
           <a:p>
@@ -7837,14 +7837,84 @@
                 </a:solidFill>
                 <a:latin typeface="Arial"/>
               </a:rPr>
-              <a:t>Diseña 4 propuestas de logo para [nombre / sector]. Minimal, vector-like, sin texto ilegible, fondo blanco. Luego elige 1 y dame variantes en negro y color.</a:t>
-            </a:r>
-          </a:p>
-        </p:txBody>
-      </p:sp>
-      <p:sp>
-        <p:nvSpPr>
-          <p:cNvPr id="9" name="TextBox 8"/>
+              <a:t>No es “hazme un logo”. Es: contar quién eres → pedir direcciones distintas → elegir una → iterar → sacar variantes útiles (negro, color, favicon).</a:t>
+            </a:r>
+          </a:p>
+        </p:txBody>
+      </p:sp>
+      <p:sp>
+        <p:nvSpPr>
+          <p:cNvPr id="9" name="Rounded Rectangle 8"/>
+          <p:cNvSpPr/>
+          <p:nvPr/>
+        </p:nvSpPr>
+        <p:spPr>
+          <a:xfrm>
+            <a:off x="3657600" y="4480559"/>
+            <a:ext cx="7863840" cy="1554480"/>
+          </a:xfrm>
+          <a:prstGeom prst="roundRect">
+            <a:avLst/>
+          </a:prstGeom>
+          <a:solidFill>
+            <a:srgbClr val="F5F5F5"/>
+          </a:solidFill>
+          <a:ln>
+            <a:solidFill>
+              <a:srgbClr val="E5E5E5"/>
+            </a:solidFill>
+          </a:ln>
+        </p:spPr>
+        <p:style>
+          <a:lnRef idx="1">
+            <a:schemeClr val="accent1"/>
+          </a:lnRef>
+          <a:fillRef idx="3">
+            <a:schemeClr val="accent1"/>
+          </a:fillRef>
+          <a:effectRef idx="2">
+            <a:schemeClr val="accent1"/>
+          </a:effectRef>
+          <a:fontRef idx="minor">
+            <a:schemeClr val="lt1"/>
+          </a:fontRef>
+        </p:style>
+        <p:txBody>
+          <a:bodyPr rtlCol="0" anchor="ctr" wrap="square"/>
+          <a:lstStyle/>
+          <a:p>
+            <a:pPr algn="ctr"/>
+            <a:r>
+              <a:rPr sz="1100" b="1">
+                <a:solidFill>
+                  <a:srgbClr val="0A0A0A"/>
+                </a:solidFill>
+                <a:latin typeface="Arial"/>
+              </a:rPr>
+              <a:t>Prompt</a:t>
+            </a:r>
+          </a:p>
+          <a:p>
+            <a:pPr>
+              <a:lnSpc>
+                <a:spcPct val="115000"/>
+              </a:lnSpc>
+            </a:pPr>
+            <a:r>
+              <a:rPr sz="1300">
+                <a:solidFill>
+                  <a:srgbClr val="525252"/>
+                </a:solidFill>
+                <a:latin typeface="Arial"/>
+              </a:rPr>
+              <a:t>Soy [nombre]. Hago [qué]. Mi buyer es [1 línea del BUYER.md]. Quiero 4 logos muy distintos entre sí: 1) símbolo solo, 2) tipografía fuerte, 3) icono + nombre, 4) sello/badge. Estilo limpio, fondo blanco, sin efectos 3D ni texto borroso. Para cada uno: idea detrás + por qué encaja. Luego dime cuál recomiendas y genera esa en negro, en color y versión pequeña para favicon.</a:t>
+            </a:r>
+          </a:p>
+        </p:txBody>
+      </p:sp>
+      <p:sp>
+        <p:nvSpPr>
+          <p:cNvPr id="10" name="TextBox 9"/>
           <p:cNvSpPr txBox="1"/>
           <p:nvPr/>
         </p:nvSpPr>

</xml_diff>

<commit_message>
fix: remove Cositas extra section divider slide
Co-authored-by: Cursor <cursoragent@cursor.com>
</commit_message>
<xml_diff>
--- a/curso-web-aje-ourense/taller-web-aje-ourense.pptx
+++ b/curso-web-aje-ourense/taller-web-aje-ourense.pptx
@@ -32,7 +32,6 @@
     <p:sldId id="280" r:id="rId31"/>
     <p:sldId id="281" r:id="rId32"/>
     <p:sldId id="282" r:id="rId33"/>
-    <p:sldId id="283" r:id="rId34"/>
   </p:sldIdLst>
   <p:sldSz cx="12191695" cy="6858000" type="screen4x3"/>
   <p:notesSz cx="6858000" cy="9144000"/>
@@ -3365,7 +3364,7 @@
                 </a:solidFill>
                 <a:latin typeface="Arial"/>
               </a:rPr>
-              <a:t>1/28</a:t>
+              <a:t>1/27</a:t>
             </a:r>
           </a:p>
         </p:txBody>
@@ -3567,7 +3566,7 @@
                 </a:solidFill>
                 <a:latin typeface="Arial"/>
               </a:rPr>
-              <a:t>10/28</a:t>
+              <a:t>10/27</a:t>
             </a:r>
           </a:p>
         </p:txBody>
@@ -3903,7 +3902,7 @@
                 </a:solidFill>
                 <a:latin typeface="Arial"/>
               </a:rPr>
-              <a:t>11/28</a:t>
+              <a:t>11/27</a:t>
             </a:r>
           </a:p>
         </p:txBody>
@@ -4305,7 +4304,7 @@
                 </a:solidFill>
                 <a:latin typeface="Arial"/>
               </a:rPr>
-              <a:t>12/28</a:t>
+              <a:t>12/27</a:t>
             </a:r>
           </a:p>
         </p:txBody>
@@ -4707,7 +4706,7 @@
                 </a:solidFill>
                 <a:latin typeface="Arial"/>
               </a:rPr>
-              <a:t>13/28</a:t>
+              <a:t>13/27</a:t>
             </a:r>
           </a:p>
         </p:txBody>
@@ -4893,7 +4892,7 @@
                 </a:solidFill>
                 <a:latin typeface="Arial"/>
               </a:rPr>
-              <a:t>14/28</a:t>
+              <a:t>14/27</a:t>
             </a:r>
           </a:p>
         </p:txBody>
@@ -5151,7 +5150,7 @@
                 </a:solidFill>
                 <a:latin typeface="Arial"/>
               </a:rPr>
-              <a:t>15/28</a:t>
+              <a:t>15/27</a:t>
             </a:r>
           </a:p>
         </p:txBody>
@@ -5553,7 +5552,7 @@
                 </a:solidFill>
                 <a:latin typeface="Arial"/>
               </a:rPr>
-              <a:t>16/28</a:t>
+              <a:t>16/27</a:t>
             </a:r>
           </a:p>
         </p:txBody>
@@ -5865,7 +5864,7 @@
                 </a:solidFill>
                 <a:latin typeface="Arial"/>
               </a:rPr>
-              <a:t>17/28</a:t>
+              <a:t>17/27</a:t>
             </a:r>
           </a:p>
         </p:txBody>
@@ -6267,7 +6266,7 @@
                 </a:solidFill>
                 <a:latin typeface="Arial"/>
               </a:rPr>
-              <a:t>18/28</a:t>
+              <a:t>18/27</a:t>
             </a:r>
           </a:p>
         </p:txBody>
@@ -6599,7 +6598,7 @@
                 </a:solidFill>
                 <a:latin typeface="Arial"/>
               </a:rPr>
-              <a:t>19/28</a:t>
+              <a:t>19/27</a:t>
             </a:r>
           </a:p>
         </p:txBody>
@@ -7142,7 +7141,7 @@
                 </a:solidFill>
                 <a:latin typeface="Arial"/>
               </a:rPr>
-              <a:t>2/28</a:t>
+              <a:t>2/27</a:t>
             </a:r>
           </a:p>
         </p:txBody>
@@ -7544,7 +7543,7 @@
                 </a:solidFill>
                 <a:latin typeface="Arial"/>
               </a:rPr>
-              <a:t>20/28</a:t>
+              <a:t>20/27</a:t>
             </a:r>
           </a:p>
         </p:txBody>
@@ -7946,7 +7945,7 @@
                 </a:solidFill>
                 <a:latin typeface="Arial"/>
               </a:rPr>
-              <a:t>21/28</a:t>
+              <a:t>21/27</a:t>
             </a:r>
           </a:p>
         </p:txBody>
@@ -8228,7 +8227,7 @@
                 </a:solidFill>
                 <a:latin typeface="Arial"/>
               </a:rPr>
-              <a:t>22/28</a:t>
+              <a:t>22/27</a:t>
             </a:r>
           </a:p>
         </p:txBody>
@@ -8525,7 +8524,7 @@
                 </a:solidFill>
                 <a:latin typeface="Arial"/>
               </a:rPr>
-              <a:t>23/28</a:t>
+              <a:t>23/27</a:t>
             </a:r>
           </a:p>
         </p:txBody>
@@ -8826,7 +8825,7 @@
                 </a:solidFill>
                 <a:latin typeface="Arial"/>
               </a:rPr>
-              <a:t>24/28</a:t>
+              <a:t>24/27</a:t>
             </a:r>
           </a:p>
         </p:txBody>
@@ -8845,7 +8844,7 @@
     <p:bg>
       <p:bgPr>
         <a:solidFill>
-          <a:srgbClr val="0A0A0A"/>
+          <a:srgbClr val="FFFFFF"/>
         </a:solidFill>
         <a:effectLst/>
       </p:bgPr>
@@ -8857,16 +8856,131 @@
         <p:nvPr/>
       </p:nvGrpSpPr>
       <p:grpSpPr/>
-      <p:sp>
-        <p:nvSpPr>
-          <p:cNvPr id="2" name="TextBox 1"/>
+      <p:pic>
+        <p:nvPicPr>
+          <p:cNvPr id="2" name="Picture 1" descr="rural-hackers.png"/>
+          <p:cNvPicPr>
+            <a:picLocks noChangeAspect="1"/>
+          </p:cNvPicPr>
+          <p:nvPr/>
+        </p:nvPicPr>
+        <p:blipFill>
+          <a:blip r:embed="rId2"/>
+          <a:stretch>
+            <a:fillRect/>
+          </a:stretch>
+        </p:blipFill>
+        <p:spPr>
+          <a:xfrm>
+            <a:off x="640080" y="384048"/>
+            <a:ext cx="256552" cy="365760"/>
+          </a:xfrm>
+          <a:prstGeom prst="rect">
+            <a:avLst/>
+          </a:prstGeom>
+        </p:spPr>
+      </p:pic>
+      <p:pic>
+        <p:nvPicPr>
+          <p:cNvPr id="3" name="Picture 2" descr="aje-ourense.png"/>
+          <p:cNvPicPr>
+            <a:picLocks noChangeAspect="1"/>
+          </p:cNvPicPr>
+          <p:nvPr/>
+        </p:nvPicPr>
+        <p:blipFill>
+          <a:blip r:embed="rId3"/>
+          <a:stretch>
+            <a:fillRect/>
+          </a:stretch>
+        </p:blipFill>
+        <p:spPr>
+          <a:xfrm>
+            <a:off x="10287000" y="384048"/>
+            <a:ext cx="920151" cy="365760"/>
+          </a:xfrm>
+          <a:prstGeom prst="rect">
+            <a:avLst/>
+          </a:prstGeom>
+        </p:spPr>
+      </p:pic>
+      <p:sp>
+        <p:nvSpPr>
+          <p:cNvPr id="4" name="Rectangle 3"/>
+          <p:cNvSpPr/>
+          <p:nvPr/>
+        </p:nvSpPr>
+        <p:spPr>
+          <a:xfrm>
+            <a:off x="594360" y="914400"/>
+            <a:ext cx="10972800" cy="9144"/>
+          </a:xfrm>
+          <a:prstGeom prst="rect">
+            <a:avLst/>
+          </a:prstGeom>
+          <a:solidFill>
+            <a:srgbClr val="E5E5E5"/>
+          </a:solidFill>
+          <a:ln>
+            <a:noFill/>
+          </a:ln>
+        </p:spPr>
+        <p:style>
+          <a:lnRef idx="1">
+            <a:schemeClr val="accent1"/>
+          </a:lnRef>
+          <a:fillRef idx="3">
+            <a:schemeClr val="accent1"/>
+          </a:fillRef>
+          <a:effectRef idx="2">
+            <a:schemeClr val="accent1"/>
+          </a:effectRef>
+          <a:fontRef idx="minor">
+            <a:schemeClr val="lt1"/>
+          </a:fontRef>
+        </p:style>
+        <p:txBody>
+          <a:bodyPr rtlCol="0" anchor="ctr"/>
+          <a:lstStyle/>
+          <a:p>
+            <a:pPr algn="ctr"/>
+          </a:p>
+        </p:txBody>
+      </p:sp>
+      <p:pic>
+        <p:nvPicPr>
+          <p:cNvPr id="5" name="Picture 4" descr="doodle-skills-superpowers.png"/>
+          <p:cNvPicPr>
+            <a:picLocks noChangeAspect="1"/>
+          </p:cNvPicPr>
+          <p:nvPr/>
+        </p:nvPicPr>
+        <p:blipFill>
+          <a:blip r:embed="rId4"/>
+          <a:stretch>
+            <a:fillRect/>
+          </a:stretch>
+        </p:blipFill>
+        <p:spPr>
+          <a:xfrm>
+            <a:off x="4769967" y="1280160"/>
+            <a:ext cx="2651760" cy="2651760"/>
+          </a:xfrm>
+          <a:prstGeom prst="rect">
+            <a:avLst/>
+          </a:prstGeom>
+        </p:spPr>
+      </p:pic>
+      <p:sp>
+        <p:nvSpPr>
+          <p:cNvPr id="6" name="TextBox 5"/>
           <p:cNvSpPr txBox="1"/>
           <p:nvPr/>
         </p:nvSpPr>
         <p:spPr>
           <a:xfrm>
-            <a:off x="822960" y="1828800"/>
-            <a:ext cx="10515600" cy="365760"/>
+            <a:off x="822960" y="3840480"/>
+            <a:ext cx="10515600" cy="640080"/>
           </a:xfrm>
           <a:prstGeom prst="rect">
             <a:avLst/>
@@ -8881,31 +8995,31 @@
           <a:p>
             <a:pPr algn="ctr">
               <a:lnSpc>
-                <a:spcPct val="120000"/>
+                <a:spcPct val="95000"/>
               </a:lnSpc>
             </a:pPr>
             <a:r>
-              <a:rPr sz="1400" b="1">
-                <a:solidFill>
-                  <a:srgbClr val="A3A3A3"/>
-                </a:solidFill>
-                <a:latin typeface="Arial"/>
-              </a:rPr>
-              <a:t>EXTRA</a:t>
-            </a:r>
-          </a:p>
-        </p:txBody>
-      </p:sp>
-      <p:sp>
-        <p:nvSpPr>
-          <p:cNvPr id="3" name="TextBox 2"/>
+              <a:rPr sz="3400" b="1">
+                <a:solidFill>
+                  <a:srgbClr val="0A0A0A"/>
+                </a:solidFill>
+                <a:latin typeface="Arial"/>
+              </a:rPr>
+              <a:t>¿Qué son los skills?</a:t>
+            </a:r>
+          </a:p>
+        </p:txBody>
+      </p:sp>
+      <p:sp>
+        <p:nvSpPr>
+          <p:cNvPr id="7" name="TextBox 6"/>
           <p:cNvSpPr txBox="1"/>
           <p:nvPr/>
         </p:nvSpPr>
         <p:spPr>
           <a:xfrm>
-            <a:off x="822960" y="2377440"/>
-            <a:ext cx="10515600" cy="2194560"/>
+            <a:off x="1097280" y="4526280"/>
+            <a:ext cx="9966960" cy="502920"/>
           </a:xfrm>
           <a:prstGeom prst="rect">
             <a:avLst/>
@@ -8920,67 +9034,186 @@
           <a:p>
             <a:pPr algn="ctr">
               <a:lnSpc>
-                <a:spcPct val="92000"/>
+                <a:spcPct val="125000"/>
               </a:lnSpc>
             </a:pPr>
             <a:r>
-              <a:rPr sz="7200" b="1">
-                <a:solidFill>
-                  <a:srgbClr val="FFFFFF"/>
-                </a:solidFill>
-                <a:latin typeface="Arial"/>
-              </a:rPr>
-              <a:t>Cositas</a:t>
-            </a:r>
-            <a:br/>
-            <a:r>
-              <a:t>extra</a:t>
-            </a:r>
-          </a:p>
-        </p:txBody>
-      </p:sp>
-      <p:sp>
-        <p:nvSpPr>
-          <p:cNvPr id="4" name="TextBox 3"/>
-          <p:cNvSpPr txBox="1"/>
-          <p:nvPr/>
-        </p:nvSpPr>
-        <p:spPr>
-          <a:xfrm>
-            <a:off x="1371600" y="4846320"/>
-            <a:ext cx="9418320" cy="640080"/>
-          </a:xfrm>
-          <a:prstGeom prst="rect">
-            <a:avLst/>
-          </a:prstGeom>
-          <a:noFill/>
-        </p:spPr>
-        <p:txBody>
-          <a:bodyPr wrap="square">
-            <a:spAutoFit/>
-          </a:bodyPr>
-          <a:lstStyle/>
-          <a:p>
-            <a:pPr algn="ctr">
-              <a:lnSpc>
-                <a:spcPct val="130000"/>
-              </a:lnSpc>
-            </a:pPr>
-            <a:r>
-              <a:rPr sz="2200" b="0">
-                <a:solidFill>
-                  <a:srgbClr val="A3A3A3"/>
-                </a:solidFill>
-                <a:latin typeface="Arial"/>
-              </a:rPr>
-              <a:t>Potencia para no quedarte a medias</a:t>
-            </a:r>
-          </a:p>
-        </p:txBody>
-      </p:sp>
-      <p:sp>
-        <p:nvSpPr>
-          <p:cNvPr id="5" name="TextBox 4"/>
+              <a:rPr sz="1600" b="0">
+                <a:solidFill>
+                  <a:srgbClr val="525252"/>
+                </a:solidFill>
+                <a:latin typeface="Arial"/>
+              </a:rPr>
+              <a:t>Instrucciones listas para la IA: como superpoderes que activas cuando los necesitas.</a:t>
+            </a:r>
+          </a:p>
+        </p:txBody>
+      </p:sp>
+      <p:sp>
+        <p:nvSpPr>
+          <p:cNvPr id="8" name="Rounded Rectangle 7"/>
+          <p:cNvSpPr/>
+          <p:nvPr/>
+        </p:nvSpPr>
+        <p:spPr>
+          <a:xfrm>
+            <a:off x="2849727" y="5074920"/>
+            <a:ext cx="2011680" cy="384048"/>
+          </a:xfrm>
+          <a:prstGeom prst="roundRect">
+            <a:avLst/>
+          </a:prstGeom>
+          <a:solidFill>
+            <a:srgbClr val="FFFFFF"/>
+          </a:solidFill>
+          <a:ln>
+            <a:solidFill>
+              <a:srgbClr val="E5E5E5"/>
+            </a:solidFill>
+          </a:ln>
+        </p:spPr>
+        <p:style>
+          <a:lnRef idx="1">
+            <a:schemeClr val="accent1"/>
+          </a:lnRef>
+          <a:fillRef idx="3">
+            <a:schemeClr val="accent1"/>
+          </a:fillRef>
+          <a:effectRef idx="2">
+            <a:schemeClr val="accent1"/>
+          </a:effectRef>
+          <a:fontRef idx="minor">
+            <a:schemeClr val="lt1"/>
+          </a:fontRef>
+        </p:style>
+        <p:txBody>
+          <a:bodyPr rtlCol="0" anchor="ctr"/>
+          <a:lstStyle/>
+          <a:p>
+            <a:pPr algn="ctr"/>
+            <a:r>
+              <a:rPr sz="1400" b="1">
+                <a:solidFill>
+                  <a:srgbClr val="525252"/>
+                </a:solidFill>
+                <a:latin typeface="Arial"/>
+              </a:rPr>
+              <a:t>Idiomas</a:t>
+            </a:r>
+          </a:p>
+        </p:txBody>
+      </p:sp>
+      <p:sp>
+        <p:nvSpPr>
+          <p:cNvPr id="9" name="Rounded Rectangle 8"/>
+          <p:cNvSpPr/>
+          <p:nvPr/>
+        </p:nvSpPr>
+        <p:spPr>
+          <a:xfrm>
+            <a:off x="5090007" y="5074920"/>
+            <a:ext cx="2011680" cy="384048"/>
+          </a:xfrm>
+          <a:prstGeom prst="roundRect">
+            <a:avLst/>
+          </a:prstGeom>
+          <a:solidFill>
+            <a:srgbClr val="FFFFFF"/>
+          </a:solidFill>
+          <a:ln>
+            <a:solidFill>
+              <a:srgbClr val="E5E5E5"/>
+            </a:solidFill>
+          </a:ln>
+        </p:spPr>
+        <p:style>
+          <a:lnRef idx="1">
+            <a:schemeClr val="accent1"/>
+          </a:lnRef>
+          <a:fillRef idx="3">
+            <a:schemeClr val="accent1"/>
+          </a:fillRef>
+          <a:effectRef idx="2">
+            <a:schemeClr val="accent1"/>
+          </a:effectRef>
+          <a:fontRef idx="minor">
+            <a:schemeClr val="lt1"/>
+          </a:fontRef>
+        </p:style>
+        <p:txBody>
+          <a:bodyPr rtlCol="0" anchor="ctr"/>
+          <a:lstStyle/>
+          <a:p>
+            <a:pPr algn="ctr"/>
+            <a:r>
+              <a:rPr sz="1400" b="1">
+                <a:solidFill>
+                  <a:srgbClr val="525252"/>
+                </a:solidFill>
+                <a:latin typeface="Arial"/>
+              </a:rPr>
+              <a:t>SEO</a:t>
+            </a:r>
+          </a:p>
+        </p:txBody>
+      </p:sp>
+      <p:sp>
+        <p:nvSpPr>
+          <p:cNvPr id="10" name="Rounded Rectangle 9"/>
+          <p:cNvSpPr/>
+          <p:nvPr/>
+        </p:nvSpPr>
+        <p:spPr>
+          <a:xfrm>
+            <a:off x="7330287" y="5074920"/>
+            <a:ext cx="2011680" cy="384048"/>
+          </a:xfrm>
+          <a:prstGeom prst="roundRect">
+            <a:avLst/>
+          </a:prstGeom>
+          <a:solidFill>
+            <a:srgbClr val="FFFFFF"/>
+          </a:solidFill>
+          <a:ln>
+            <a:solidFill>
+              <a:srgbClr val="E5E5E5"/>
+            </a:solidFill>
+          </a:ln>
+        </p:spPr>
+        <p:style>
+          <a:lnRef idx="1">
+            <a:schemeClr val="accent1"/>
+          </a:lnRef>
+          <a:fillRef idx="3">
+            <a:schemeClr val="accent1"/>
+          </a:fillRef>
+          <a:effectRef idx="2">
+            <a:schemeClr val="accent1"/>
+          </a:effectRef>
+          <a:fontRef idx="minor">
+            <a:schemeClr val="lt1"/>
+          </a:fontRef>
+        </p:style>
+        <p:txBody>
+          <a:bodyPr rtlCol="0" anchor="ctr"/>
+          <a:lstStyle/>
+          <a:p>
+            <a:pPr algn="ctr"/>
+            <a:r>
+              <a:rPr sz="1400" b="1">
+                <a:solidFill>
+                  <a:srgbClr val="525252"/>
+                </a:solidFill>
+                <a:latin typeface="Arial"/>
+              </a:rPr>
+              <a:t>Claridad UX</a:t>
+            </a:r>
+          </a:p>
+        </p:txBody>
+      </p:sp>
+      <p:sp>
+        <p:nvSpPr>
+          <p:cNvPr id="11" name="TextBox 10"/>
           <p:cNvSpPr txBox="1"/>
           <p:nvPr/>
         </p:nvSpPr>
@@ -9008,11 +9241,11 @@
             <a:r>
               <a:rPr sz="1100" b="0">
                 <a:solidFill>
-                  <a:srgbClr val="E5E5E5"/>
-                </a:solidFill>
-                <a:latin typeface="Arial"/>
-              </a:rPr>
-              <a:t>25/28</a:t>
+                  <a:srgbClr val="A3A3A3"/>
+                </a:solidFill>
+                <a:latin typeface="Arial"/>
+              </a:rPr>
+              <a:t>25/27</a:t>
             </a:r>
           </a:p>
         </p:txBody>
@@ -9134,40 +9367,16 @@
           </a:p>
         </p:txBody>
       </p:sp>
-      <p:pic>
-        <p:nvPicPr>
-          <p:cNvPr id="5" name="Picture 4" descr="doodle-skills-superpowers.png"/>
-          <p:cNvPicPr>
-            <a:picLocks noChangeAspect="1"/>
-          </p:cNvPicPr>
-          <p:nvPr/>
-        </p:nvPicPr>
-        <p:blipFill>
-          <a:blip r:embed="rId4"/>
-          <a:stretch>
-            <a:fillRect/>
-          </a:stretch>
-        </p:blipFill>
-        <p:spPr>
-          <a:xfrm>
-            <a:off x="4769967" y="1280160"/>
-            <a:ext cx="2651760" cy="2651760"/>
-          </a:xfrm>
-          <a:prstGeom prst="rect">
-            <a:avLst/>
-          </a:prstGeom>
-        </p:spPr>
-      </p:pic>
-      <p:sp>
-        <p:nvSpPr>
-          <p:cNvPr id="6" name="TextBox 5"/>
+      <p:sp>
+        <p:nvSpPr>
+          <p:cNvPr id="5" name="TextBox 4"/>
           <p:cNvSpPr txBox="1"/>
           <p:nvPr/>
         </p:nvSpPr>
         <p:spPr>
           <a:xfrm>
-            <a:off x="822960" y="3840480"/>
-            <a:ext cx="10515600" cy="640080"/>
+            <a:off x="822960" y="2560320"/>
+            <a:ext cx="10515600" cy="1828800"/>
           </a:xfrm>
           <a:prstGeom prst="rect">
             <a:avLst/>
@@ -9182,225 +9391,24 @@
           <a:p>
             <a:pPr algn="ctr">
               <a:lnSpc>
-                <a:spcPct val="95000"/>
+                <a:spcPct val="105000"/>
               </a:lnSpc>
             </a:pPr>
             <a:r>
-              <a:rPr sz="3400" b="1">
+              <a:rPr sz="6000" b="1">
                 <a:solidFill>
                   <a:srgbClr val="0A0A0A"/>
                 </a:solidFill>
                 <a:latin typeface="Arial"/>
               </a:rPr>
-              <a:t>¿Qué son los skills?</a:t>
-            </a:r>
-          </a:p>
-        </p:txBody>
-      </p:sp>
-      <p:sp>
-        <p:nvSpPr>
-          <p:cNvPr id="7" name="TextBox 6"/>
-          <p:cNvSpPr txBox="1"/>
-          <p:nvPr/>
-        </p:nvSpPr>
-        <p:spPr>
-          <a:xfrm>
-            <a:off x="1097280" y="4526280"/>
-            <a:ext cx="9966960" cy="502920"/>
-          </a:xfrm>
-          <a:prstGeom prst="rect">
-            <a:avLst/>
-          </a:prstGeom>
-          <a:noFill/>
-        </p:spPr>
-        <p:txBody>
-          <a:bodyPr wrap="square">
-            <a:spAutoFit/>
-          </a:bodyPr>
-          <a:lstStyle/>
-          <a:p>
-            <a:pPr algn="ctr">
-              <a:lnSpc>
-                <a:spcPct val="125000"/>
-              </a:lnSpc>
-            </a:pPr>
-            <a:r>
-              <a:rPr sz="1600" b="0">
-                <a:solidFill>
-                  <a:srgbClr val="525252"/>
-                </a:solidFill>
-                <a:latin typeface="Arial"/>
-              </a:rPr>
-              <a:t>Instrucciones listas para la IA: como superpoderes que activas cuando los necesitas.</a:t>
-            </a:r>
-          </a:p>
-        </p:txBody>
-      </p:sp>
-      <p:sp>
-        <p:nvSpPr>
-          <p:cNvPr id="8" name="Rounded Rectangle 7"/>
-          <p:cNvSpPr/>
-          <p:nvPr/>
-        </p:nvSpPr>
-        <p:spPr>
-          <a:xfrm>
-            <a:off x="2849727" y="5074920"/>
-            <a:ext cx="2011680" cy="384048"/>
-          </a:xfrm>
-          <a:prstGeom prst="roundRect">
-            <a:avLst/>
-          </a:prstGeom>
-          <a:solidFill>
-            <a:srgbClr val="FFFFFF"/>
-          </a:solidFill>
-          <a:ln>
-            <a:solidFill>
-              <a:srgbClr val="E5E5E5"/>
-            </a:solidFill>
-          </a:ln>
-        </p:spPr>
-        <p:style>
-          <a:lnRef idx="1">
-            <a:schemeClr val="accent1"/>
-          </a:lnRef>
-          <a:fillRef idx="3">
-            <a:schemeClr val="accent1"/>
-          </a:fillRef>
-          <a:effectRef idx="2">
-            <a:schemeClr val="accent1"/>
-          </a:effectRef>
-          <a:fontRef idx="minor">
-            <a:schemeClr val="lt1"/>
-          </a:fontRef>
-        </p:style>
-        <p:txBody>
-          <a:bodyPr rtlCol="0" anchor="ctr"/>
-          <a:lstStyle/>
-          <a:p>
-            <a:pPr algn="ctr"/>
-            <a:r>
-              <a:rPr sz="1400" b="1">
-                <a:solidFill>
-                  <a:srgbClr val="525252"/>
-                </a:solidFill>
-                <a:latin typeface="Arial"/>
-              </a:rPr>
-              <a:t>Idiomas</a:t>
-            </a:r>
-          </a:p>
-        </p:txBody>
-      </p:sp>
-      <p:sp>
-        <p:nvSpPr>
-          <p:cNvPr id="9" name="Rounded Rectangle 8"/>
-          <p:cNvSpPr/>
-          <p:nvPr/>
-        </p:nvSpPr>
-        <p:spPr>
-          <a:xfrm>
-            <a:off x="5090007" y="5074920"/>
-            <a:ext cx="2011680" cy="384048"/>
-          </a:xfrm>
-          <a:prstGeom prst="roundRect">
-            <a:avLst/>
-          </a:prstGeom>
-          <a:solidFill>
-            <a:srgbClr val="FFFFFF"/>
-          </a:solidFill>
-          <a:ln>
-            <a:solidFill>
-              <a:srgbClr val="E5E5E5"/>
-            </a:solidFill>
-          </a:ln>
-        </p:spPr>
-        <p:style>
-          <a:lnRef idx="1">
-            <a:schemeClr val="accent1"/>
-          </a:lnRef>
-          <a:fillRef idx="3">
-            <a:schemeClr val="accent1"/>
-          </a:fillRef>
-          <a:effectRef idx="2">
-            <a:schemeClr val="accent1"/>
-          </a:effectRef>
-          <a:fontRef idx="minor">
-            <a:schemeClr val="lt1"/>
-          </a:fontRef>
-        </p:style>
-        <p:txBody>
-          <a:bodyPr rtlCol="0" anchor="ctr"/>
-          <a:lstStyle/>
-          <a:p>
-            <a:pPr algn="ctr"/>
-            <a:r>
-              <a:rPr sz="1400" b="1">
-                <a:solidFill>
-                  <a:srgbClr val="525252"/>
-                </a:solidFill>
-                <a:latin typeface="Arial"/>
-              </a:rPr>
-              <a:t>SEO</a:t>
-            </a:r>
-          </a:p>
-        </p:txBody>
-      </p:sp>
-      <p:sp>
-        <p:nvSpPr>
-          <p:cNvPr id="10" name="Rounded Rectangle 9"/>
-          <p:cNvSpPr/>
-          <p:nvPr/>
-        </p:nvSpPr>
-        <p:spPr>
-          <a:xfrm>
-            <a:off x="7330287" y="5074920"/>
-            <a:ext cx="2011680" cy="384048"/>
-          </a:xfrm>
-          <a:prstGeom prst="roundRect">
-            <a:avLst/>
-          </a:prstGeom>
-          <a:solidFill>
-            <a:srgbClr val="FFFFFF"/>
-          </a:solidFill>
-          <a:ln>
-            <a:solidFill>
-              <a:srgbClr val="E5E5E5"/>
-            </a:solidFill>
-          </a:ln>
-        </p:spPr>
-        <p:style>
-          <a:lnRef idx="1">
-            <a:schemeClr val="accent1"/>
-          </a:lnRef>
-          <a:fillRef idx="3">
-            <a:schemeClr val="accent1"/>
-          </a:fillRef>
-          <a:effectRef idx="2">
-            <a:schemeClr val="accent1"/>
-          </a:effectRef>
-          <a:fontRef idx="minor">
-            <a:schemeClr val="lt1"/>
-          </a:fontRef>
-        </p:style>
-        <p:txBody>
-          <a:bodyPr rtlCol="0" anchor="ctr"/>
-          <a:lstStyle/>
-          <a:p>
-            <a:pPr algn="ctr"/>
-            <a:r>
-              <a:rPr sz="1400" b="1">
-                <a:solidFill>
-                  <a:srgbClr val="525252"/>
-                </a:solidFill>
-                <a:latin typeface="Arial"/>
-              </a:rPr>
-              <a:t>Claridad UX</a:t>
-            </a:r>
-          </a:p>
-        </p:txBody>
-      </p:sp>
-      <p:sp>
-        <p:nvSpPr>
-          <p:cNvPr id="11" name="TextBox 10"/>
+              <a:t>Tu dibujo → tu web</a:t>
+            </a:r>
+          </a:p>
+        </p:txBody>
+      </p:sp>
+      <p:sp>
+        <p:nvSpPr>
+          <p:cNvPr id="6" name="TextBox 5"/>
           <p:cNvSpPr txBox="1"/>
           <p:nvPr/>
         </p:nvSpPr>
@@ -9432,7 +9440,7 @@
                 </a:solidFill>
                 <a:latin typeface="Arial"/>
               </a:rPr>
-              <a:t>26/28</a:t>
+              <a:t>26/27</a:t>
             </a:r>
           </a:p>
         </p:txBody>
@@ -9588,7 +9596,7 @@
                 </a:solidFill>
                 <a:latin typeface="Arial"/>
               </a:rPr>
-              <a:t>Tu dibujo → tu web</a:t>
+              <a:t>Qué te llevas hoy</a:t>
             </a:r>
           </a:p>
         </p:txBody>
@@ -9627,202 +9635,7 @@
                 </a:solidFill>
                 <a:latin typeface="Arial"/>
               </a:rPr>
-              <a:t>27/28</a:t>
-            </a:r>
-          </a:p>
-        </p:txBody>
-      </p:sp>
-    </p:spTree>
-  </p:cSld>
-  <p:clrMapOvr>
-    <a:masterClrMapping/>
-  </p:clrMapOvr>
-</p:sld>
-</file>
-
-<file path=ppt/slides/slide28.xml><?xml version="1.0" encoding="utf-8"?>
-<p:sld xmlns:a="http://schemas.openxmlformats.org/drawingml/2006/main" xmlns:p="http://schemas.openxmlformats.org/presentationml/2006/main" xmlns:r="http://schemas.openxmlformats.org/officeDocument/2006/relationships">
-  <p:cSld>
-    <p:bg>
-      <p:bgPr>
-        <a:solidFill>
-          <a:srgbClr val="FFFFFF"/>
-        </a:solidFill>
-        <a:effectLst/>
-      </p:bgPr>
-    </p:bg>
-    <p:spTree>
-      <p:nvGrpSpPr>
-        <p:cNvPr id="1" name=""/>
-        <p:cNvGrpSpPr/>
-        <p:nvPr/>
-      </p:nvGrpSpPr>
-      <p:grpSpPr/>
-      <p:pic>
-        <p:nvPicPr>
-          <p:cNvPr id="2" name="Picture 1" descr="rural-hackers.png"/>
-          <p:cNvPicPr>
-            <a:picLocks noChangeAspect="1"/>
-          </p:cNvPicPr>
-          <p:nvPr/>
-        </p:nvPicPr>
-        <p:blipFill>
-          <a:blip r:embed="rId2"/>
-          <a:stretch>
-            <a:fillRect/>
-          </a:stretch>
-        </p:blipFill>
-        <p:spPr>
-          <a:xfrm>
-            <a:off x="640080" y="384048"/>
-            <a:ext cx="256552" cy="365760"/>
-          </a:xfrm>
-          <a:prstGeom prst="rect">
-            <a:avLst/>
-          </a:prstGeom>
-        </p:spPr>
-      </p:pic>
-      <p:pic>
-        <p:nvPicPr>
-          <p:cNvPr id="3" name="Picture 2" descr="aje-ourense.png"/>
-          <p:cNvPicPr>
-            <a:picLocks noChangeAspect="1"/>
-          </p:cNvPicPr>
-          <p:nvPr/>
-        </p:nvPicPr>
-        <p:blipFill>
-          <a:blip r:embed="rId3"/>
-          <a:stretch>
-            <a:fillRect/>
-          </a:stretch>
-        </p:blipFill>
-        <p:spPr>
-          <a:xfrm>
-            <a:off x="10287000" y="384048"/>
-            <a:ext cx="920151" cy="365760"/>
-          </a:xfrm>
-          <a:prstGeom prst="rect">
-            <a:avLst/>
-          </a:prstGeom>
-        </p:spPr>
-      </p:pic>
-      <p:sp>
-        <p:nvSpPr>
-          <p:cNvPr id="4" name="Rectangle 3"/>
-          <p:cNvSpPr/>
-          <p:nvPr/>
-        </p:nvSpPr>
-        <p:spPr>
-          <a:xfrm>
-            <a:off x="594360" y="914400"/>
-            <a:ext cx="10972800" cy="9144"/>
-          </a:xfrm>
-          <a:prstGeom prst="rect">
-            <a:avLst/>
-          </a:prstGeom>
-          <a:solidFill>
-            <a:srgbClr val="E5E5E5"/>
-          </a:solidFill>
-          <a:ln>
-            <a:noFill/>
-          </a:ln>
-        </p:spPr>
-        <p:style>
-          <a:lnRef idx="1">
-            <a:schemeClr val="accent1"/>
-          </a:lnRef>
-          <a:fillRef idx="3">
-            <a:schemeClr val="accent1"/>
-          </a:fillRef>
-          <a:effectRef idx="2">
-            <a:schemeClr val="accent1"/>
-          </a:effectRef>
-          <a:fontRef idx="minor">
-            <a:schemeClr val="lt1"/>
-          </a:fontRef>
-        </p:style>
-        <p:txBody>
-          <a:bodyPr rtlCol="0" anchor="ctr"/>
-          <a:lstStyle/>
-          <a:p>
-            <a:pPr algn="ctr"/>
-          </a:p>
-        </p:txBody>
-      </p:sp>
-      <p:sp>
-        <p:nvSpPr>
-          <p:cNvPr id="5" name="TextBox 4"/>
-          <p:cNvSpPr txBox="1"/>
-          <p:nvPr/>
-        </p:nvSpPr>
-        <p:spPr>
-          <a:xfrm>
-            <a:off x="822960" y="2560320"/>
-            <a:ext cx="10515600" cy="1828800"/>
-          </a:xfrm>
-          <a:prstGeom prst="rect">
-            <a:avLst/>
-          </a:prstGeom>
-          <a:noFill/>
-        </p:spPr>
-        <p:txBody>
-          <a:bodyPr wrap="square">
-            <a:spAutoFit/>
-          </a:bodyPr>
-          <a:lstStyle/>
-          <a:p>
-            <a:pPr algn="ctr">
-              <a:lnSpc>
-                <a:spcPct val="105000"/>
-              </a:lnSpc>
-            </a:pPr>
-            <a:r>
-              <a:rPr sz="6000" b="1">
-                <a:solidFill>
-                  <a:srgbClr val="0A0A0A"/>
-                </a:solidFill>
-                <a:latin typeface="Arial"/>
-              </a:rPr>
-              <a:t>Qué te llevas hoy</a:t>
-            </a:r>
-          </a:p>
-        </p:txBody>
-      </p:sp>
-      <p:sp>
-        <p:nvSpPr>
-          <p:cNvPr id="6" name="TextBox 5"/>
-          <p:cNvSpPr txBox="1"/>
-          <p:nvPr/>
-        </p:nvSpPr>
-        <p:spPr>
-          <a:xfrm>
-            <a:off x="10881360" y="6473952"/>
-            <a:ext cx="1097280" cy="228600"/>
-          </a:xfrm>
-          <a:prstGeom prst="rect">
-            <a:avLst/>
-          </a:prstGeom>
-          <a:noFill/>
-        </p:spPr>
-        <p:txBody>
-          <a:bodyPr wrap="square">
-            <a:spAutoFit/>
-          </a:bodyPr>
-          <a:lstStyle/>
-          <a:p>
-            <a:pPr algn="r">
-              <a:lnSpc>
-                <a:spcPct val="120000"/>
-              </a:lnSpc>
-            </a:pPr>
-            <a:r>
-              <a:rPr sz="1100" b="0">
-                <a:solidFill>
-                  <a:srgbClr val="A3A3A3"/>
-                </a:solidFill>
-                <a:latin typeface="Arial"/>
-              </a:rPr>
-              <a:t>28/28</a:t>
+              <a:t>27/27</a:t>
             </a:r>
           </a:p>
         </p:txBody>
@@ -10080,7 +9893,7 @@
                 </a:solidFill>
                 <a:latin typeface="Arial"/>
               </a:rPr>
-              <a:t>3/28</a:t>
+              <a:t>3/27</a:t>
             </a:r>
           </a:p>
         </p:txBody>
@@ -10299,7 +10112,7 @@
                 </a:solidFill>
                 <a:latin typeface="Arial"/>
               </a:rPr>
-              <a:t>4/28</a:t>
+              <a:t>4/27</a:t>
             </a:r>
           </a:p>
         </p:txBody>
@@ -10518,7 +10331,7 @@
                 </a:solidFill>
                 <a:latin typeface="Arial"/>
               </a:rPr>
-              <a:t>5/28</a:t>
+              <a:t>5/27</a:t>
             </a:r>
           </a:p>
         </p:txBody>
@@ -10834,7 +10647,7 @@
                 </a:solidFill>
                 <a:latin typeface="Arial"/>
               </a:rPr>
-              <a:t>6/28</a:t>
+              <a:t>6/27</a:t>
             </a:r>
           </a:p>
         </p:txBody>
@@ -11185,7 +10998,7 @@
                 </a:solidFill>
                 <a:latin typeface="Arial"/>
               </a:rPr>
-              <a:t>7/28</a:t>
+              <a:t>7/27</a:t>
             </a:r>
           </a:p>
         </p:txBody>
@@ -11512,7 +11325,7 @@
                 </a:solidFill>
                 <a:latin typeface="Arial"/>
               </a:rPr>
-              <a:t>8/28</a:t>
+              <a:t>8/27</a:t>
             </a:r>
           </a:p>
         </p:txBody>
@@ -11867,7 +11680,7 @@
                 </a:solidFill>
                 <a:latin typeface="Arial"/>
               </a:rPr>
-              <a:t>9/28</a:t>
+              <a:t>9/27</a:t>
             </a:r>
           </a:p>
         </p:txBody>

</xml_diff>

<commit_message>
feat: before-after doodle slide for dibujo to web
Co-authored-by: Cursor <cursoragent@cursor.com>
</commit_message>
<xml_diff>
--- a/curso-web-aje-ourense/taller-web-aje-ourense.pptx
+++ b/curso-web-aje-ourense/taller-web-aje-ourense.pptx
@@ -5030,7 +5030,7 @@
         </p:blipFill>
         <p:spPr>
           <a:xfrm>
-            <a:off x="4769967" y="1280160"/>
+            <a:off x="4769967" y="1097280"/>
             <a:ext cx="2651760" cy="2651760"/>
           </a:xfrm>
           <a:prstGeom prst="rect">
@@ -5046,7 +5046,7 @@
         </p:nvSpPr>
         <p:spPr>
           <a:xfrm>
-            <a:off x="822960" y="3840480"/>
+            <a:off x="822960" y="3428122358880"/>
             <a:ext cx="10515600" cy="640080"/>
           </a:xfrm>
           <a:prstGeom prst="rect">
@@ -5085,7 +5085,7 @@
         </p:nvSpPr>
         <p:spPr>
           <a:xfrm>
-            <a:off x="1097280" y="4526280"/>
+            <a:off x="1097280" y="3428123044680"/>
             <a:ext cx="9966960" cy="502920"/>
           </a:xfrm>
           <a:prstGeom prst="rect">
@@ -5105,7 +5105,7 @@
               </a:lnSpc>
             </a:pPr>
             <a:r>
-              <a:rPr sz="1600" b="0">
+              <a:rPr sz="1800" b="0">
                 <a:solidFill>
                   <a:srgbClr val="525252"/>
                 </a:solidFill>
@@ -5690,7 +5690,7 @@
         </p:blipFill>
         <p:spPr>
           <a:xfrm>
-            <a:off x="4769967" y="1280160"/>
+            <a:off x="4769967" y="1097280"/>
             <a:ext cx="2651760" cy="2651760"/>
           </a:xfrm>
           <a:prstGeom prst="rect">
@@ -5706,7 +5706,7 @@
         </p:nvSpPr>
         <p:spPr>
           <a:xfrm>
-            <a:off x="822960" y="3840480"/>
+            <a:off x="822960" y="3428122358880"/>
             <a:ext cx="10515600" cy="640080"/>
           </a:xfrm>
           <a:prstGeom prst="rect">
@@ -5745,7 +5745,7 @@
         </p:nvSpPr>
         <p:spPr>
           <a:xfrm>
-            <a:off x="1097280" y="4526280"/>
+            <a:off x="1097280" y="3428123044680"/>
             <a:ext cx="9966960" cy="502920"/>
           </a:xfrm>
           <a:prstGeom prst="rect">
@@ -5765,7 +5765,7 @@
               </a:lnSpc>
             </a:pPr>
             <a:r>
-              <a:rPr sz="1600" b="0">
+              <a:rPr sz="1800" b="0">
                 <a:solidFill>
                   <a:srgbClr val="525252"/>
                 </a:solidFill>
@@ -5784,7 +5784,7 @@
         </p:nvSpPr>
         <p:spPr>
           <a:xfrm>
-            <a:off x="5090007" y="5074920"/>
+            <a:off x="5090007" y="3428123547600"/>
             <a:ext cx="2011680" cy="384048"/>
           </a:xfrm>
           <a:prstGeom prst="roundRect">
@@ -8365,7 +8365,7 @@
         </p:blipFill>
         <p:spPr>
           <a:xfrm>
-            <a:off x="4769967" y="1280160"/>
+            <a:off x="4769967" y="1097280"/>
             <a:ext cx="2651760" cy="2651760"/>
           </a:xfrm>
           <a:prstGeom prst="rect">
@@ -8381,7 +8381,7 @@
         </p:nvSpPr>
         <p:spPr>
           <a:xfrm>
-            <a:off x="822960" y="3840480"/>
+            <a:off x="822960" y="3428122358880"/>
             <a:ext cx="10515600" cy="640080"/>
           </a:xfrm>
           <a:prstGeom prst="rect">
@@ -8420,7 +8420,7 @@
         </p:nvSpPr>
         <p:spPr>
           <a:xfrm>
-            <a:off x="822960" y="4526280"/>
+            <a:off x="822960" y="3428123044680"/>
             <a:ext cx="10515600" cy="365760"/>
           </a:xfrm>
           <a:prstGeom prst="rect">
@@ -8459,7 +8459,7 @@
         </p:nvSpPr>
         <p:spPr>
           <a:xfrm>
-            <a:off x="1097280" y="4937760"/>
+            <a:off x="1097280" y="3428123456160"/>
             <a:ext cx="9966960" cy="502920"/>
           </a:xfrm>
           <a:prstGeom prst="rect">
@@ -8479,7 +8479,7 @@
               </a:lnSpc>
             </a:pPr>
             <a:r>
-              <a:rPr sz="1600" b="0">
+              <a:rPr sz="1800" b="0">
                 <a:solidFill>
                   <a:srgbClr val="525252"/>
                 </a:solidFill>
@@ -8662,7 +8662,7 @@
         </p:blipFill>
         <p:spPr>
           <a:xfrm>
-            <a:off x="4769967" y="1280160"/>
+            <a:off x="4769967" y="1097280"/>
             <a:ext cx="2651760" cy="2651760"/>
           </a:xfrm>
           <a:prstGeom prst="rect">
@@ -8678,7 +8678,7 @@
         </p:nvSpPr>
         <p:spPr>
           <a:xfrm>
-            <a:off x="822960" y="3840480"/>
+            <a:off x="822960" y="3428122358880"/>
             <a:ext cx="10515600" cy="640080"/>
           </a:xfrm>
           <a:prstGeom prst="rect">
@@ -8721,7 +8721,7 @@
         </p:nvSpPr>
         <p:spPr>
           <a:xfrm>
-            <a:off x="822960" y="4526280"/>
+            <a:off x="822960" y="3428123044680"/>
             <a:ext cx="10515600" cy="365760"/>
           </a:xfrm>
           <a:prstGeom prst="rect">
@@ -8760,7 +8760,7 @@
         </p:nvSpPr>
         <p:spPr>
           <a:xfrm>
-            <a:off x="1097280" y="4937760"/>
+            <a:off x="1097280" y="3428123456160"/>
             <a:ext cx="9966960" cy="502920"/>
           </a:xfrm>
           <a:prstGeom prst="rect">
@@ -8780,7 +8780,7 @@
               </a:lnSpc>
             </a:pPr>
             <a:r>
-              <a:rPr sz="1600" b="0">
+              <a:rPr sz="1800" b="0">
                 <a:solidFill>
                   <a:srgbClr val="525252"/>
                 </a:solidFill>
@@ -8963,7 +8963,7 @@
         </p:blipFill>
         <p:spPr>
           <a:xfrm>
-            <a:off x="4769967" y="1280160"/>
+            <a:off x="4769967" y="1097280"/>
             <a:ext cx="2651760" cy="2651760"/>
           </a:xfrm>
           <a:prstGeom prst="rect">
@@ -8979,7 +8979,7 @@
         </p:nvSpPr>
         <p:spPr>
           <a:xfrm>
-            <a:off x="822960" y="3840480"/>
+            <a:off x="822960" y="3428122358880"/>
             <a:ext cx="10515600" cy="640080"/>
           </a:xfrm>
           <a:prstGeom prst="rect">
@@ -9018,7 +9018,7 @@
         </p:nvSpPr>
         <p:spPr>
           <a:xfrm>
-            <a:off x="1097280" y="4526280"/>
+            <a:off x="1097280" y="3428123044680"/>
             <a:ext cx="9966960" cy="502920"/>
           </a:xfrm>
           <a:prstGeom prst="rect">
@@ -9038,7 +9038,7 @@
               </a:lnSpc>
             </a:pPr>
             <a:r>
-              <a:rPr sz="1600" b="0">
+              <a:rPr sz="1800" b="0">
                 <a:solidFill>
                   <a:srgbClr val="525252"/>
                 </a:solidFill>
@@ -9057,7 +9057,7 @@
         </p:nvSpPr>
         <p:spPr>
           <a:xfrm>
-            <a:off x="2849727" y="5074920"/>
+            <a:off x="2849727" y="3428123547600"/>
             <a:ext cx="2011680" cy="384048"/>
           </a:xfrm>
           <a:prstGeom prst="roundRect">
@@ -9111,7 +9111,7 @@
         </p:nvSpPr>
         <p:spPr>
           <a:xfrm>
-            <a:off x="5090007" y="5074920"/>
+            <a:off x="5090007" y="3428123547600"/>
             <a:ext cx="2011680" cy="384048"/>
           </a:xfrm>
           <a:prstGeom prst="roundRect">
@@ -9165,7 +9165,7 @@
         </p:nvSpPr>
         <p:spPr>
           <a:xfrm>
-            <a:off x="7330287" y="5074920"/>
+            <a:off x="7330287" y="3428123547600"/>
             <a:ext cx="2011680" cy="384048"/>
           </a:xfrm>
           <a:prstGeom prst="roundRect">
@@ -9369,14 +9369,146 @@
       </p:sp>
       <p:sp>
         <p:nvSpPr>
-          <p:cNvPr id="5" name="TextBox 4"/>
+          <p:cNvPr id="5" name="Rounded Rectangle 4"/>
+          <p:cNvSpPr/>
+          <p:nvPr/>
+        </p:nvSpPr>
+        <p:spPr>
+          <a:xfrm>
+            <a:off x="3969867" y="1097280"/>
+            <a:ext cx="2011680" cy="365760"/>
+          </a:xfrm>
+          <a:prstGeom prst="roundRect">
+            <a:avLst/>
+          </a:prstGeom>
+          <a:solidFill>
+            <a:srgbClr val="FFFFFF"/>
+          </a:solidFill>
+          <a:ln>
+            <a:solidFill>
+              <a:srgbClr val="E5E5E5"/>
+            </a:solidFill>
+          </a:ln>
+        </p:spPr>
+        <p:style>
+          <a:lnRef idx="1">
+            <a:schemeClr val="accent1"/>
+          </a:lnRef>
+          <a:fillRef idx="3">
+            <a:schemeClr val="accent1"/>
+          </a:fillRef>
+          <a:effectRef idx="2">
+            <a:schemeClr val="accent1"/>
+          </a:effectRef>
+          <a:fontRef idx="minor">
+            <a:schemeClr val="lt1"/>
+          </a:fontRef>
+        </p:style>
+        <p:txBody>
+          <a:bodyPr rtlCol="0" anchor="ctr"/>
+          <a:lstStyle/>
+          <a:p>
+            <a:pPr algn="ctr"/>
+            <a:r>
+              <a:rPr sz="1400" b="1">
+                <a:solidFill>
+                  <a:srgbClr val="525252"/>
+                </a:solidFill>
+                <a:latin typeface="Arial"/>
+              </a:rPr>
+              <a:t>Tu dibujo</a:t>
+            </a:r>
+          </a:p>
+        </p:txBody>
+      </p:sp>
+      <p:sp>
+        <p:nvSpPr>
+          <p:cNvPr id="6" name="Rounded Rectangle 5"/>
+          <p:cNvSpPr/>
+          <p:nvPr/>
+        </p:nvSpPr>
+        <p:spPr>
+          <a:xfrm>
+            <a:off x="6210147" y="1097280"/>
+            <a:ext cx="2011680" cy="365760"/>
+          </a:xfrm>
+          <a:prstGeom prst="roundRect">
+            <a:avLst/>
+          </a:prstGeom>
+          <a:solidFill>
+            <a:srgbClr val="FFFFFF"/>
+          </a:solidFill>
+          <a:ln>
+            <a:solidFill>
+              <a:srgbClr val="E5E5E5"/>
+            </a:solidFill>
+          </a:ln>
+        </p:spPr>
+        <p:style>
+          <a:lnRef idx="1">
+            <a:schemeClr val="accent1"/>
+          </a:lnRef>
+          <a:fillRef idx="3">
+            <a:schemeClr val="accent1"/>
+          </a:fillRef>
+          <a:effectRef idx="2">
+            <a:schemeClr val="accent1"/>
+          </a:effectRef>
+          <a:fontRef idx="minor">
+            <a:schemeClr val="lt1"/>
+          </a:fontRef>
+        </p:style>
+        <p:txBody>
+          <a:bodyPr rtlCol="0" anchor="ctr"/>
+          <a:lstStyle/>
+          <a:p>
+            <a:pPr algn="ctr"/>
+            <a:r>
+              <a:rPr sz="1400" b="1">
+                <a:solidFill>
+                  <a:srgbClr val="525252"/>
+                </a:solidFill>
+                <a:latin typeface="Arial"/>
+              </a:rPr>
+              <a:t>Tu web</a:t>
+            </a:r>
+          </a:p>
+        </p:txBody>
+      </p:sp>
+      <p:pic>
+        <p:nvPicPr>
+          <p:cNvPr id="7" name="Picture 6" descr="doodle-dibujo-web.png"/>
+          <p:cNvPicPr>
+            <a:picLocks noChangeAspect="1"/>
+          </p:cNvPicPr>
+          <p:nvPr/>
+        </p:nvPicPr>
+        <p:blipFill>
+          <a:blip r:embed="rId4"/>
+          <a:stretch>
+            <a:fillRect/>
+          </a:stretch>
+        </p:blipFill>
+        <p:spPr>
+          <a:xfrm>
+            <a:off x="1097280" y="1600200"/>
+            <a:ext cx="9966960" cy="5606415"/>
+          </a:xfrm>
+          <a:prstGeom prst="rect">
+            <a:avLst/>
+          </a:prstGeom>
+        </p:spPr>
+      </p:pic>
+      <p:sp>
+        <p:nvSpPr>
+          <p:cNvPr id="8" name="TextBox 7"/>
           <p:cNvSpPr txBox="1"/>
           <p:nvPr/>
         </p:nvSpPr>
         <p:spPr>
           <a:xfrm>
-            <a:off x="822960" y="2560320"/>
-            <a:ext cx="10515600" cy="1828800"/>
+            <a:off x="1097280" y="6589728938880"/>
+            <a:ext cx="9966960" cy="502920"/>
           </a:xfrm>
           <a:prstGeom prst="rect">
             <a:avLst/>
@@ -9391,24 +9523,24 @@
           <a:p>
             <a:pPr algn="ctr">
               <a:lnSpc>
-                <a:spcPct val="105000"/>
+                <a:spcPct val="125000"/>
               </a:lnSpc>
             </a:pPr>
             <a:r>
-              <a:rPr sz="6000" b="1">
-                <a:solidFill>
-                  <a:srgbClr val="0A0A0A"/>
-                </a:solidFill>
-                <a:latin typeface="Arial"/>
-              </a:rPr>
-              <a:t>Tu dibujo → tu web</a:t>
-            </a:r>
-          </a:p>
-        </p:txBody>
-      </p:sp>
-      <p:sp>
-        <p:nvSpPr>
-          <p:cNvPr id="6" name="TextBox 5"/>
+              <a:rPr sz="1800" b="0">
+                <a:solidFill>
+                  <a:srgbClr val="525252"/>
+                </a:solidFill>
+                <a:latin typeface="Arial"/>
+              </a:rPr>
+              <a:t>Del folio al navegador</a:t>
+            </a:r>
+          </a:p>
+        </p:txBody>
+      </p:sp>
+      <p:sp>
+        <p:nvSpPr>
+          <p:cNvPr id="9" name="TextBox 8"/>
           <p:cNvSpPr txBox="1"/>
           <p:nvPr/>
         </p:nvSpPr>
@@ -9765,7 +9897,7 @@
         </p:nvSpPr>
         <p:spPr>
           <a:xfrm>
-            <a:off x="822960" y="1051560"/>
+            <a:off x="822960" y="1097280"/>
             <a:ext cx="10515600" cy="274320"/>
           </a:xfrm>
           <a:prstGeom prst="rect">
@@ -9812,7 +9944,7 @@
         </p:blipFill>
         <p:spPr>
           <a:xfrm>
-            <a:off x="4769967" y="1280160"/>
+            <a:off x="4769967" y="1417319"/>
             <a:ext cx="2651760" cy="2651760"/>
           </a:xfrm>
           <a:prstGeom prst="rect">
@@ -9828,7 +9960,7 @@
         </p:nvSpPr>
         <p:spPr>
           <a:xfrm>
-            <a:off x="822960" y="3840480"/>
+            <a:off x="822960" y="3720766020480"/>
             <a:ext cx="10515600" cy="640080"/>
           </a:xfrm>
           <a:prstGeom prst="rect">
@@ -10031,7 +10163,7 @@
         </p:blipFill>
         <p:spPr>
           <a:xfrm>
-            <a:off x="4328007" y="1280160"/>
+            <a:off x="4328007" y="1097280"/>
             <a:ext cx="3535680" cy="2651760"/>
           </a:xfrm>
           <a:prstGeom prst="rect">
@@ -10047,7 +10179,7 @@
         </p:nvSpPr>
         <p:spPr>
           <a:xfrm>
-            <a:off x="822960" y="3840480"/>
+            <a:off x="822960" y="3428122358880"/>
             <a:ext cx="10515600" cy="640080"/>
           </a:xfrm>
           <a:prstGeom prst="rect">
@@ -11136,7 +11268,7 @@
         </p:blipFill>
         <p:spPr>
           <a:xfrm>
-            <a:off x="4769967" y="1280160"/>
+            <a:off x="4769967" y="1097280"/>
             <a:ext cx="2651760" cy="2651760"/>
           </a:xfrm>
           <a:prstGeom prst="rect">
@@ -11152,7 +11284,7 @@
         </p:nvSpPr>
         <p:spPr>
           <a:xfrm>
-            <a:off x="822960" y="3840480"/>
+            <a:off x="822960" y="3428122358880"/>
             <a:ext cx="10515600" cy="640080"/>
           </a:xfrm>
           <a:prstGeom prst="rect">
@@ -11191,7 +11323,7 @@
         </p:nvSpPr>
         <p:spPr>
           <a:xfrm>
-            <a:off x="3969867" y="4526280"/>
+            <a:off x="3969867" y="3428123044680"/>
             <a:ext cx="2011680" cy="384048"/>
           </a:xfrm>
           <a:prstGeom prst="roundRect">
@@ -11245,7 +11377,7 @@
         </p:nvSpPr>
         <p:spPr>
           <a:xfrm>
-            <a:off x="6210147" y="4526280"/>
+            <a:off x="6210147" y="3428123044680"/>
             <a:ext cx="2011680" cy="384048"/>
           </a:xfrm>
           <a:prstGeom prst="roundRect">

</xml_diff>

<commit_message>
feat: passionate stickman doodle on closing takeaways slide
Co-authored-by: Cursor <cursoragent@cursor.com>
</commit_message>
<xml_diff>
--- a/curso-web-aje-ourense/taller-web-aje-ourense.pptx
+++ b/curso-web-aje-ourense/taller-web-aje-ourense.pptx
@@ -9694,16 +9694,40 @@
           </a:p>
         </p:txBody>
       </p:sp>
-      <p:sp>
-        <p:nvSpPr>
-          <p:cNvPr id="5" name="TextBox 4"/>
+      <p:pic>
+        <p:nvPicPr>
+          <p:cNvPr id="5" name="Picture 4" descr="doodle-que-te-llevas.png"/>
+          <p:cNvPicPr>
+            <a:picLocks noChangeAspect="1"/>
+          </p:cNvPicPr>
+          <p:nvPr/>
+        </p:nvPicPr>
+        <p:blipFill>
+          <a:blip r:embed="rId4"/>
+          <a:stretch>
+            <a:fillRect/>
+          </a:stretch>
+        </p:blipFill>
+        <p:spPr>
+          <a:xfrm>
+            <a:off x="4769967" y="1097280"/>
+            <a:ext cx="2651760" cy="2651760"/>
+          </a:xfrm>
+          <a:prstGeom prst="rect">
+            <a:avLst/>
+          </a:prstGeom>
+        </p:spPr>
+      </p:pic>
+      <p:sp>
+        <p:nvSpPr>
+          <p:cNvPr id="6" name="TextBox 5"/>
           <p:cNvSpPr txBox="1"/>
           <p:nvPr/>
         </p:nvSpPr>
         <p:spPr>
           <a:xfrm>
-            <a:off x="822960" y="2560320"/>
-            <a:ext cx="10515600" cy="1828800"/>
+            <a:off x="822960" y="3428122358880"/>
+            <a:ext cx="10515600" cy="640080"/>
           </a:xfrm>
           <a:prstGeom prst="rect">
             <a:avLst/>
@@ -9718,11 +9742,11 @@
           <a:p>
             <a:pPr algn="ctr">
               <a:lnSpc>
-                <a:spcPct val="105000"/>
+                <a:spcPct val="95000"/>
               </a:lnSpc>
             </a:pPr>
             <a:r>
-              <a:rPr sz="6000" b="1">
+              <a:rPr sz="3400" b="1">
                 <a:solidFill>
                   <a:srgbClr val="0A0A0A"/>
                 </a:solidFill>
@@ -9735,7 +9759,7 @@
       </p:sp>
       <p:sp>
         <p:nvSpPr>
-          <p:cNvPr id="6" name="TextBox 5"/>
+          <p:cNvPr id="7" name="TextBox 6"/>
           <p:cNvSpPr txBox="1"/>
           <p:nvPr/>
         </p:nvSpPr>

</xml_diff>